<commit_message>
Add matching themed images to each sermon slide
Co-authored-by: M8J1T <M8T1J@users.noreply.github.com>
</commit_message>
<xml_diff>
--- a/Endless_Revival_Through_Prayer.pptx
+++ b/Endless_Revival_Through_Prayer.pptx
@@ -3107,11 +3107,19 @@
             <p:ph type="ctrTitle"/>
           </p:nvPr>
         </p:nvSpPr>
-        <p:spPr/>
-        <p:txBody>
-          <a:bodyPr/>
-          <a:lstStyle/>
-          <a:p>
+        <p:spPr>
+          <a:xfrm>
+            <a:off x="640080" y="731520"/>
+            <a:ext cx="6400800" cy="0"/>
+          </a:xfrm>
+        </p:spPr>
+        <p:txBody>
+          <a:bodyPr/>
+          <a:lstStyle/>
+          <a:p>
+            <a:pPr>
+              <a:defRPr sz="4200"/>
+            </a:pPr>
             <a:r>
               <a:t>WATCH • LISTEN • TESTIFY</a:t>
             </a:r>
@@ -3128,24 +3136,57 @@
             <p:ph type="subTitle" idx="1"/>
           </p:nvPr>
         </p:nvSpPr>
-        <p:spPr/>
-        <p:txBody>
-          <a:bodyPr/>
-          <a:lstStyle/>
-          <a:p>
-            <a:r>
-              <a:rPr sz="2400"/>
+        <p:spPr>
+          <a:xfrm>
+            <a:off x="731520" y="2194560"/>
+            <a:ext cx="6217920" cy="1828800"/>
+          </a:xfrm>
+        </p:spPr>
+        <p:txBody>
+          <a:bodyPr/>
+          <a:lstStyle/>
+          <a:p>
+            <a:pPr>
+              <a:defRPr sz="2400"/>
+            </a:pPr>
+            <a:r>
               <a:t>Endless Revival Through Prayer</a:t>
             </a:r>
           </a:p>
           <a:p>
-            <a:r>
-              <a:rPr sz="2400"/>
+            <a:pPr>
+              <a:defRPr sz="2400"/>
+            </a:pPr>
+            <a:r>
               <a:t>Main Text: James 5:17</a:t>
             </a:r>
           </a:p>
         </p:txBody>
       </p:sp>
+      <p:pic>
+        <p:nvPicPr>
+          <p:cNvPr id="4" name="Picture 3" descr="01-title.png"/>
+          <p:cNvPicPr>
+            <a:picLocks noChangeAspect="1"/>
+          </p:cNvPicPr>
+          <p:nvPr/>
+        </p:nvPicPr>
+        <p:blipFill>
+          <a:blip r:embed="rId2"/>
+          <a:stretch>
+            <a:fillRect/>
+          </a:stretch>
+        </p:blipFill>
+        <p:spPr>
+          <a:xfrm>
+            <a:off x="6675120" y="640080"/>
+            <a:ext cx="5120640" cy="5486400"/>
+          </a:xfrm>
+          <a:prstGeom prst="rect">
+            <a:avLst/>
+          </a:prstGeom>
+        </p:spPr>
+      </p:pic>
     </p:spTree>
   </p:cSld>
   <p:clrMapOvr>
@@ -3174,11 +3215,19 @@
             <p:ph type="title"/>
           </p:nvPr>
         </p:nvSpPr>
-        <p:spPr/>
-        <p:txBody>
-          <a:bodyPr/>
-          <a:lstStyle/>
-          <a:p>
+        <p:spPr>
+          <a:xfrm>
+            <a:off x="457200" y="320040"/>
+            <a:ext cx="6675120" cy="822960"/>
+          </a:xfrm>
+        </p:spPr>
+        <p:txBody>
+          <a:bodyPr/>
+          <a:lstStyle/>
+          <a:p>
+            <a:pPr>
+              <a:defRPr sz="3400"/>
+            </a:pPr>
             <a:r>
               <a:t>ALTAR CALL</a:t>
             </a:r>
@@ -3195,13 +3244,18 @@
             <p:ph idx="1"/>
           </p:nvPr>
         </p:nvSpPr>
-        <p:spPr/>
-        <p:txBody>
-          <a:bodyPr/>
-          <a:lstStyle/>
-          <a:p>
-            <a:pPr>
-              <a:defRPr sz="1800"/>
+        <p:spPr>
+          <a:xfrm>
+            <a:off x="548640" y="1188720"/>
+            <a:ext cx="6309360" cy="5303520"/>
+          </a:xfrm>
+        </p:spPr>
+        <p:txBody>
+          <a:bodyPr wrap="square"/>
+          <a:lstStyle/>
+          <a:p>
+            <a:pPr>
+              <a:defRPr sz="1500"/>
             </a:pPr>
             <a:r>
               <a:t>Stand, not for hype, but for surrender</a:t>
@@ -3209,7 +3263,7 @@
           </a:p>
           <a:p>
             <a:pPr>
-              <a:defRPr sz="1800"/>
+              <a:defRPr sz="1500"/>
             </a:pPr>
             <a:r>
               <a:t>Pray:</a:t>
@@ -3217,7 +3271,7 @@
           </a:p>
           <a:p>
             <a:pPr>
-              <a:defRPr sz="1800"/>
+              <a:defRPr sz="1500"/>
             </a:pPr>
             <a:r>
               <a:t>"Father,</a:t>
@@ -3225,7 +3279,7 @@
           </a:p>
           <a:p>
             <a:pPr>
-              <a:defRPr sz="1800"/>
+              <a:defRPr sz="1500"/>
             </a:pPr>
             <a:r>
               <a:t>Press us if You must.</a:t>
@@ -3233,7 +3287,7 @@
           </a:p>
           <a:p>
             <a:pPr>
-              <a:defRPr sz="1800"/>
+              <a:defRPr sz="1500"/>
             </a:pPr>
             <a:r>
               <a:t>Crush pride. Remove distraction. Align our hearts with Yours.</a:t>
@@ -3241,7 +3295,7 @@
           </a:p>
           <a:p>
             <a:pPr>
-              <a:defRPr sz="1800"/>
+              <a:defRPr sz="1500"/>
             </a:pPr>
             <a:r>
               <a:t>Make us watchers. Make us listeners. Make us faithful witnesses.</a:t>
@@ -3249,7 +3303,7 @@
           </a:p>
           <a:p>
             <a:pPr>
-              <a:defRPr sz="1800"/>
+              <a:defRPr sz="1500"/>
             </a:pPr>
             <a:r>
               <a:t>Let our prayers be powerful and effective,</a:t>
@@ -3257,7 +3311,7 @@
           </a:p>
           <a:p>
             <a:pPr>
-              <a:defRPr sz="1800"/>
+              <a:defRPr sz="1500"/>
             </a:pPr>
             <a:r>
               <a:t>Not because we control heaven,</a:t>
@@ -3265,7 +3319,7 @@
           </a:p>
           <a:p>
             <a:pPr>
-              <a:defRPr sz="1800"/>
+              <a:defRPr sz="1500"/>
             </a:pPr>
             <a:r>
               <a:t>But because we walk with You.</a:t>
@@ -3273,7 +3327,7 @@
           </a:p>
           <a:p>
             <a:pPr>
-              <a:defRPr sz="1800"/>
+              <a:defRPr sz="1500"/>
             </a:pPr>
             <a:r>
               <a:t>Let revival be endless,</a:t>
@@ -3281,7 +3335,7 @@
           </a:p>
           <a:p>
             <a:pPr>
-              <a:defRPr sz="1800"/>
+              <a:defRPr sz="1500"/>
             </a:pPr>
             <a:r>
               <a:t>Because obedience is continual.</a:t>
@@ -3289,7 +3343,7 @@
           </a:p>
           <a:p>
             <a:pPr>
-              <a:defRPr sz="1800"/>
+              <a:defRPr sz="1500"/>
             </a:pPr>
             <a:r>
               <a:t>In Jesus' name, Amen."</a:t>
@@ -3297,6 +3351,30 @@
           </a:p>
         </p:txBody>
       </p:sp>
+      <p:pic>
+        <p:nvPicPr>
+          <p:cNvPr id="4" name="Picture 3" descr="10-altar-call.png"/>
+          <p:cNvPicPr>
+            <a:picLocks noChangeAspect="1"/>
+          </p:cNvPicPr>
+          <p:nvPr/>
+        </p:nvPicPr>
+        <p:blipFill>
+          <a:blip r:embed="rId2"/>
+          <a:stretch>
+            <a:fillRect/>
+          </a:stretch>
+        </p:blipFill>
+        <p:spPr>
+          <a:xfrm>
+            <a:off x="7040880" y="1143000"/>
+            <a:ext cx="4663440" cy="4663440"/>
+          </a:xfrm>
+          <a:prstGeom prst="rect">
+            <a:avLst/>
+          </a:prstGeom>
+        </p:spPr>
+      </p:pic>
     </p:spTree>
   </p:cSld>
   <p:clrMapOvr>
@@ -3325,11 +3403,19 @@
             <p:ph type="title"/>
           </p:nvPr>
         </p:nvSpPr>
-        <p:spPr/>
-        <p:txBody>
-          <a:bodyPr/>
-          <a:lstStyle/>
-          <a:p>
+        <p:spPr>
+          <a:xfrm>
+            <a:off x="457200" y="320040"/>
+            <a:ext cx="6675120" cy="822960"/>
+          </a:xfrm>
+        </p:spPr>
+        <p:txBody>
+          <a:bodyPr/>
+          <a:lstStyle/>
+          <a:p>
+            <a:pPr>
+              <a:defRPr sz="3400"/>
+            </a:pPr>
             <a:r>
               <a:t>Introduction</a:t>
             </a:r>
@@ -3346,13 +3432,18 @@
             <p:ph idx="1"/>
           </p:nvPr>
         </p:nvSpPr>
-        <p:spPr/>
-        <p:txBody>
-          <a:bodyPr/>
-          <a:lstStyle/>
-          <a:p>
-            <a:pPr>
-              <a:defRPr sz="1800"/>
+        <p:spPr>
+          <a:xfrm>
+            <a:off x="548640" y="1188720"/>
+            <a:ext cx="6309360" cy="5303520"/>
+          </a:xfrm>
+        </p:spPr>
+        <p:txBody>
+          <a:bodyPr wrap="square"/>
+          <a:lstStyle/>
+          <a:p>
+            <a:pPr>
+              <a:defRPr sz="1500"/>
             </a:pPr>
             <a:r>
               <a:t>Tonight we talk about Endless Revival</a:t>
@@ -3360,7 +3451,7 @@
           </a:p>
           <a:p>
             <a:pPr>
-              <a:defRPr sz="1800"/>
+              <a:defRPr sz="1500"/>
             </a:pPr>
             <a:r>
               <a:t>Not emotional moments</a:t>
@@ -3368,7 +3459,7 @@
           </a:p>
           <a:p>
             <a:pPr>
-              <a:defRPr sz="1800"/>
+              <a:defRPr sz="1500"/>
             </a:pPr>
             <a:r>
               <a:t>Not temporary excitement</a:t>
@@ -3376,7 +3467,7 @@
           </a:p>
           <a:p>
             <a:pPr>
-              <a:defRPr sz="1800"/>
+              <a:defRPr sz="1500"/>
             </a:pPr>
             <a:r>
               <a:t>But sustained oil</a:t>
@@ -3384,7 +3475,7 @@
           </a:p>
           <a:p>
             <a:pPr>
-              <a:defRPr sz="1800"/>
+              <a:defRPr sz="1500"/>
             </a:pPr>
             <a:r>
               <a:t>James 5:17</a:t>
@@ -3392,7 +3483,7 @@
           </a:p>
           <a:p>
             <a:pPr>
-              <a:defRPr sz="1800"/>
+              <a:defRPr sz="1500"/>
             </a:pPr>
             <a:r>
               <a:t>"Elijah was a man with a nature like ours, and he prayed earnestly that it would not rain..."</a:t>
@@ -3400,7 +3491,7 @@
           </a:p>
           <a:p>
             <a:pPr>
-              <a:defRPr sz="1800"/>
+              <a:defRPr sz="1500"/>
             </a:pPr>
             <a:r>
               <a:t>Elijah was human:</a:t>
@@ -3408,7 +3499,7 @@
           </a:p>
           <a:p>
             <a:pPr lvl="1">
-              <a:defRPr sz="1600"/>
+              <a:defRPr sz="1300"/>
             </a:pPr>
             <a:r>
               <a:t>Had fears, weakness, pressure</a:t>
@@ -3416,7 +3507,7 @@
           </a:p>
           <a:p>
             <a:pPr>
-              <a:defRPr sz="1800"/>
+              <a:defRPr sz="1500"/>
             </a:pPr>
             <a:r>
               <a:t>But prayer changed a nation</a:t>
@@ -3424,7 +3515,7 @@
           </a:p>
           <a:p>
             <a:pPr>
-              <a:defRPr sz="1800"/>
+              <a:defRPr sz="1500"/>
             </a:pPr>
             <a:r>
               <a:t>Revival is sustained by:</a:t>
@@ -3432,7 +3523,7 @@
           </a:p>
           <a:p>
             <a:pPr lvl="1">
-              <a:defRPr sz="1600"/>
+              <a:defRPr sz="1300"/>
             </a:pPr>
             <a:r>
               <a:t>1) Watchfulness</a:t>
@@ -3440,7 +3531,7 @@
           </a:p>
           <a:p>
             <a:pPr lvl="1">
-              <a:defRPr sz="1600"/>
+              <a:defRPr sz="1300"/>
             </a:pPr>
             <a:r>
               <a:t>2) Obedience</a:t>
@@ -3448,7 +3539,7 @@
           </a:p>
           <a:p>
             <a:pPr lvl="1">
-              <a:defRPr sz="1600"/>
+              <a:defRPr sz="1300"/>
             </a:pPr>
             <a:r>
               <a:t>3) Testimony</a:t>
@@ -3456,7 +3547,7 @@
           </a:p>
           <a:p>
             <a:pPr>
-              <a:defRPr sz="1800"/>
+              <a:defRPr sz="1500"/>
             </a:pPr>
             <a:r>
               <a:t>Through prayer</a:t>
@@ -3464,6 +3555,30 @@
           </a:p>
         </p:txBody>
       </p:sp>
+      <p:pic>
+        <p:nvPicPr>
+          <p:cNvPr id="4" name="Picture 3" descr="02-introduction.png"/>
+          <p:cNvPicPr>
+            <a:picLocks noChangeAspect="1"/>
+          </p:cNvPicPr>
+          <p:nvPr/>
+        </p:nvPicPr>
+        <p:blipFill>
+          <a:blip r:embed="rId2"/>
+          <a:stretch>
+            <a:fillRect/>
+          </a:stretch>
+        </p:blipFill>
+        <p:spPr>
+          <a:xfrm>
+            <a:off x="7040880" y="1143000"/>
+            <a:ext cx="4663440" cy="4663440"/>
+          </a:xfrm>
+          <a:prstGeom prst="rect">
+            <a:avLst/>
+          </a:prstGeom>
+        </p:spPr>
+      </p:pic>
     </p:spTree>
   </p:cSld>
   <p:clrMapOvr>
@@ -3492,11 +3607,19 @@
             <p:ph type="title"/>
           </p:nvPr>
         </p:nvSpPr>
-        <p:spPr/>
-        <p:txBody>
-          <a:bodyPr/>
-          <a:lstStyle/>
-          <a:p>
+        <p:spPr>
+          <a:xfrm>
+            <a:off x="457200" y="320040"/>
+            <a:ext cx="6675120" cy="822960"/>
+          </a:xfrm>
+        </p:spPr>
+        <p:txBody>
+          <a:bodyPr/>
+          <a:lstStyle/>
+          <a:p>
+            <a:pPr>
+              <a:defRPr sz="3400"/>
+            </a:pPr>
             <a:r>
               <a:t>1) WATCH</a:t>
             </a:r>
@@ -3513,13 +3636,18 @@
             <p:ph idx="1"/>
           </p:nvPr>
         </p:nvSpPr>
-        <p:spPr/>
-        <p:txBody>
-          <a:bodyPr/>
-          <a:lstStyle/>
-          <a:p>
-            <a:pPr>
-              <a:defRPr sz="1800"/>
+        <p:spPr>
+          <a:xfrm>
+            <a:off x="548640" y="1188720"/>
+            <a:ext cx="6309360" cy="5303520"/>
+          </a:xfrm>
+        </p:spPr>
+        <p:txBody>
+          <a:bodyPr wrap="square"/>
+          <a:lstStyle/>
+          <a:p>
+            <a:pPr>
+              <a:defRPr sz="1600"/>
             </a:pPr>
             <a:r>
               <a:t>Before physical drought, there was spiritual drought</a:t>
@@ -3527,7 +3655,7 @@
           </a:p>
           <a:p>
             <a:pPr>
-              <a:defRPr sz="1800"/>
+              <a:defRPr sz="1600"/>
             </a:pPr>
             <a:r>
               <a:t>Israel had turned to idols</a:t>
@@ -3535,7 +3663,7 @@
           </a:p>
           <a:p>
             <a:pPr>
-              <a:defRPr sz="1800"/>
+              <a:defRPr sz="1600"/>
             </a:pPr>
             <a:r>
               <a:t>God warned: Deuteronomy 11:16-17</a:t>
@@ -3543,7 +3671,7 @@
           </a:p>
           <a:p>
             <a:pPr>
-              <a:defRPr sz="1800"/>
+              <a:defRPr sz="1600"/>
             </a:pPr>
             <a:r>
               <a:t>Elijah knew the covenant</a:t>
@@ -3551,7 +3679,7 @@
           </a:p>
           <a:p>
             <a:pPr>
-              <a:defRPr sz="1800"/>
+              <a:defRPr sz="1600"/>
             </a:pPr>
             <a:r>
               <a:t>He confronted Ahab - He was a watchman</a:t>
@@ -3559,7 +3687,7 @@
           </a:p>
           <a:p>
             <a:pPr>
-              <a:defRPr sz="1800"/>
+              <a:defRPr sz="1600"/>
             </a:pPr>
             <a:r>
               <a:t>Watching means:</a:t>
@@ -3567,46 +3695,70 @@
           </a:p>
           <a:p>
             <a:pPr lvl="1">
+              <a:defRPr sz="1400"/>
+            </a:pPr>
+            <a:r>
+              <a:t>Guard your heart</a:t>
+            </a:r>
+          </a:p>
+          <a:p>
+            <a:pPr lvl="1">
+              <a:defRPr sz="1400"/>
+            </a:pPr>
+            <a:r>
+              <a:t>Guard your home</a:t>
+            </a:r>
+          </a:p>
+          <a:p>
+            <a:pPr lvl="1">
+              <a:defRPr sz="1400"/>
+            </a:pPr>
+            <a:r>
+              <a:t>Guard your church</a:t>
+            </a:r>
+          </a:p>
+          <a:p>
+            <a:pPr>
               <a:defRPr sz="1600"/>
             </a:pPr>
             <a:r>
-              <a:t>Guard your heart</a:t>
-            </a:r>
-          </a:p>
-          <a:p>
-            <a:pPr lvl="1">
+              <a:t>Jesus said: "Watch!"</a:t>
+            </a:r>
+          </a:p>
+          <a:p>
+            <a:pPr>
               <a:defRPr sz="1600"/>
             </a:pPr>
             <a:r>
-              <a:t>Guard your home</a:t>
-            </a:r>
-          </a:p>
-          <a:p>
-            <a:pPr lvl="1">
-              <a:defRPr sz="1600"/>
-            </a:pPr>
-            <a:r>
-              <a:t>Guard your church</a:t>
-            </a:r>
-          </a:p>
-          <a:p>
-            <a:pPr>
-              <a:defRPr sz="1800"/>
-            </a:pPr>
-            <a:r>
-              <a:t>Jesus said: "Watch!"</a:t>
-            </a:r>
-          </a:p>
-          <a:p>
-            <a:pPr>
-              <a:defRPr sz="1800"/>
-            </a:pPr>
-            <a:r>
               <a:t>Revival dies when the church sleeps</a:t>
             </a:r>
           </a:p>
         </p:txBody>
       </p:sp>
+      <p:pic>
+        <p:nvPicPr>
+          <p:cNvPr id="4" name="Picture 3" descr="03-watch.png"/>
+          <p:cNvPicPr>
+            <a:picLocks noChangeAspect="1"/>
+          </p:cNvPicPr>
+          <p:nvPr/>
+        </p:nvPicPr>
+        <p:blipFill>
+          <a:blip r:embed="rId2"/>
+          <a:stretch>
+            <a:fillRect/>
+          </a:stretch>
+        </p:blipFill>
+        <p:spPr>
+          <a:xfrm>
+            <a:off x="7040880" y="1143000"/>
+            <a:ext cx="4663440" cy="4663440"/>
+          </a:xfrm>
+          <a:prstGeom prst="rect">
+            <a:avLst/>
+          </a:prstGeom>
+        </p:spPr>
+      </p:pic>
     </p:spTree>
   </p:cSld>
   <p:clrMapOvr>
@@ -3635,11 +3787,19 @@
             <p:ph type="title"/>
           </p:nvPr>
         </p:nvSpPr>
-        <p:spPr/>
-        <p:txBody>
-          <a:bodyPr/>
-          <a:lstStyle/>
-          <a:p>
+        <p:spPr>
+          <a:xfrm>
+            <a:off x="457200" y="320040"/>
+            <a:ext cx="6675120" cy="822960"/>
+          </a:xfrm>
+        </p:spPr>
+        <p:txBody>
+          <a:bodyPr/>
+          <a:lstStyle/>
+          <a:p>
+            <a:pPr>
+              <a:defRPr sz="3400"/>
+            </a:pPr>
             <a:r>
               <a:t>2) LISTEN</a:t>
             </a:r>
@@ -3656,13 +3816,18 @@
             <p:ph idx="1"/>
           </p:nvPr>
         </p:nvSpPr>
-        <p:spPr/>
-        <p:txBody>
-          <a:bodyPr/>
-          <a:lstStyle/>
-          <a:p>
-            <a:pPr>
-              <a:defRPr sz="1800"/>
+        <p:spPr>
+          <a:xfrm>
+            <a:off x="548640" y="1188720"/>
+            <a:ext cx="6309360" cy="5303520"/>
+          </a:xfrm>
+        </p:spPr>
+        <p:txBody>
+          <a:bodyPr wrap="square"/>
+          <a:lstStyle/>
+          <a:p>
+            <a:pPr>
+              <a:defRPr sz="1600"/>
             </a:pPr>
             <a:r>
               <a:t>Pattern in 1 Kings 17-18:</a:t>
@@ -3670,79 +3835,79 @@
           </a:p>
           <a:p>
             <a:pPr lvl="1">
+              <a:defRPr sz="1400"/>
+            </a:pPr>
+            <a:r>
+              <a:t>"The word of the LORD came..."</a:t>
+            </a:r>
+          </a:p>
+          <a:p>
+            <a:pPr lvl="1">
+              <a:defRPr sz="1400"/>
+            </a:pPr>
+            <a:r>
+              <a:t>Go to Cherith -&gt; Zarephath -&gt; Return to Ahab -&gt; Pray for rain</a:t>
+            </a:r>
+          </a:p>
+          <a:p>
+            <a:pPr>
               <a:defRPr sz="1600"/>
             </a:pPr>
             <a:r>
-              <a:t>"The word of the LORD came..."</a:t>
+              <a:t>Obedience produces miracles</a:t>
+            </a:r>
+          </a:p>
+          <a:p>
+            <a:pPr>
+              <a:defRPr sz="1600"/>
+            </a:pPr>
+            <a:r>
+              <a:t>Jesus said: John 5:19</a:t>
+            </a:r>
+          </a:p>
+          <a:p>
+            <a:pPr>
+              <a:defRPr sz="1600"/>
+            </a:pPr>
+            <a:r>
+              <a:t>"The Son can do nothing by Himself..."</a:t>
+            </a:r>
+          </a:p>
+          <a:p>
+            <a:pPr>
+              <a:defRPr sz="1600"/>
+            </a:pPr>
+            <a:r>
+              <a:t>Listening produces authority</a:t>
+            </a:r>
+          </a:p>
+          <a:p>
+            <a:pPr>
+              <a:defRPr sz="1600"/>
+            </a:pPr>
+            <a:r>
+              <a:t>Oil is built in hidden seasons:</a:t>
             </a:r>
           </a:p>
           <a:p>
             <a:pPr lvl="1">
-              <a:defRPr sz="1600"/>
-            </a:pPr>
-            <a:r>
-              <a:t>Go to Cherith -&gt; Zarephath -&gt; Return to Ahab -&gt; Pray for rain</a:t>
-            </a:r>
-          </a:p>
-          <a:p>
-            <a:pPr>
-              <a:defRPr sz="1800"/>
-            </a:pPr>
-            <a:r>
-              <a:t>Obedience produces miracles</a:t>
-            </a:r>
-          </a:p>
-          <a:p>
-            <a:pPr>
-              <a:defRPr sz="1800"/>
-            </a:pPr>
-            <a:r>
-              <a:t>Jesus said: John 5:19</a:t>
-            </a:r>
-          </a:p>
-          <a:p>
-            <a:pPr>
-              <a:defRPr sz="1800"/>
-            </a:pPr>
-            <a:r>
-              <a:t>"The Son can do nothing by Himself..."</a:t>
-            </a:r>
-          </a:p>
-          <a:p>
-            <a:pPr>
-              <a:defRPr sz="1800"/>
-            </a:pPr>
-            <a:r>
-              <a:t>Listening produces authority</a:t>
-            </a:r>
-          </a:p>
-          <a:p>
-            <a:pPr>
-              <a:defRPr sz="1800"/>
-            </a:pPr>
-            <a:r>
-              <a:t>Oil is built in hidden seasons:</a:t>
+              <a:defRPr sz="1400"/>
+            </a:pPr>
+            <a:r>
+              <a:t>At the brook</a:t>
             </a:r>
           </a:p>
           <a:p>
             <a:pPr lvl="1">
-              <a:defRPr sz="1600"/>
-            </a:pPr>
-            <a:r>
-              <a:t>At the brook</a:t>
+              <a:defRPr sz="1400"/>
+            </a:pPr>
+            <a:r>
+              <a:t>In the widow's house</a:t>
             </a:r>
           </a:p>
           <a:p>
             <a:pPr lvl="1">
-              <a:defRPr sz="1600"/>
-            </a:pPr>
-            <a:r>
-              <a:t>In the widow's house</a:t>
-            </a:r>
-          </a:p>
-          <a:p>
-            <a:pPr lvl="1">
-              <a:defRPr sz="1600"/>
+              <a:defRPr sz="1400"/>
             </a:pPr>
             <a:r>
               <a:t>In private prayer</a:t>
@@ -3750,6 +3915,30 @@
           </a:p>
         </p:txBody>
       </p:sp>
+      <p:pic>
+        <p:nvPicPr>
+          <p:cNvPr id="4" name="Picture 3" descr="04-listen.png"/>
+          <p:cNvPicPr>
+            <a:picLocks noChangeAspect="1"/>
+          </p:cNvPicPr>
+          <p:nvPr/>
+        </p:nvPicPr>
+        <p:blipFill>
+          <a:blip r:embed="rId2"/>
+          <a:stretch>
+            <a:fillRect/>
+          </a:stretch>
+        </p:blipFill>
+        <p:spPr>
+          <a:xfrm>
+            <a:off x="7040880" y="1143000"/>
+            <a:ext cx="4663440" cy="4663440"/>
+          </a:xfrm>
+          <a:prstGeom prst="rect">
+            <a:avLst/>
+          </a:prstGeom>
+        </p:spPr>
+      </p:pic>
     </p:spTree>
   </p:cSld>
   <p:clrMapOvr>
@@ -3778,11 +3967,19 @@
             <p:ph type="title"/>
           </p:nvPr>
         </p:nvSpPr>
-        <p:spPr/>
-        <p:txBody>
-          <a:bodyPr/>
-          <a:lstStyle/>
-          <a:p>
+        <p:spPr>
+          <a:xfrm>
+            <a:off x="457200" y="320040"/>
+            <a:ext cx="6675120" cy="822960"/>
+          </a:xfrm>
+        </p:spPr>
+        <p:txBody>
+          <a:bodyPr/>
+          <a:lstStyle/>
+          <a:p>
+            <a:pPr>
+              <a:defRPr sz="3400"/>
+            </a:pPr>
             <a:r>
               <a:t>3) THE PRESSING (THE OIL)</a:t>
             </a:r>
@@ -3799,13 +3996,18 @@
             <p:ph idx="1"/>
           </p:nvPr>
         </p:nvSpPr>
-        <p:spPr/>
-        <p:txBody>
-          <a:bodyPr/>
-          <a:lstStyle/>
-          <a:p>
-            <a:pPr>
-              <a:defRPr sz="1800"/>
+        <p:spPr>
+          <a:xfrm>
+            <a:off x="548640" y="1188720"/>
+            <a:ext cx="6309360" cy="5303520"/>
+          </a:xfrm>
+        </p:spPr>
+        <p:txBody>
+          <a:bodyPr wrap="square"/>
+          <a:lstStyle/>
+          <a:p>
+            <a:pPr>
+              <a:defRPr sz="1600"/>
             </a:pPr>
             <a:r>
               <a:t>Olives must be crushed to release oil</a:t>
@@ -3813,7 +4015,7 @@
           </a:p>
           <a:p>
             <a:pPr>
-              <a:defRPr sz="1800"/>
+              <a:defRPr sz="1600"/>
             </a:pPr>
             <a:r>
               <a:t>Elijah pressed for 3.5 years:</a:t>
@@ -3821,71 +4023,71 @@
           </a:p>
           <a:p>
             <a:pPr lvl="1">
+              <a:defRPr sz="1400"/>
+            </a:pPr>
+            <a:r>
+              <a:t>Brook dried</a:t>
+            </a:r>
+          </a:p>
+          <a:p>
+            <a:pPr lvl="1">
+              <a:defRPr sz="1400"/>
+            </a:pPr>
+            <a:r>
+              <a:t>Widow had one meal</a:t>
+            </a:r>
+          </a:p>
+          <a:p>
+            <a:pPr lvl="1">
+              <a:defRPr sz="1400"/>
+            </a:pPr>
+            <a:r>
+              <a:t>Child died</a:t>
+            </a:r>
+          </a:p>
+          <a:p>
+            <a:pPr lvl="1">
+              <a:defRPr sz="1400"/>
+            </a:pPr>
+            <a:r>
+              <a:t>Stood alone on Mount Carmel</a:t>
+            </a:r>
+          </a:p>
+          <a:p>
+            <a:pPr>
               <a:defRPr sz="1600"/>
             </a:pPr>
             <a:r>
-              <a:t>Brook dried</a:t>
-            </a:r>
-          </a:p>
-          <a:p>
-            <a:pPr lvl="1">
+              <a:t>Crushing produces oil</a:t>
+            </a:r>
+          </a:p>
+          <a:p>
+            <a:pPr>
               <a:defRPr sz="1600"/>
             </a:pPr>
             <a:r>
-              <a:t>Widow had one meal</a:t>
-            </a:r>
-          </a:p>
-          <a:p>
-            <a:pPr lvl="1">
+              <a:t>Jesus said: Luke 16:16</a:t>
+            </a:r>
+          </a:p>
+          <a:p>
+            <a:pPr>
               <a:defRPr sz="1600"/>
             </a:pPr>
             <a:r>
-              <a:t>Child died</a:t>
-            </a:r>
-          </a:p>
-          <a:p>
-            <a:pPr lvl="1">
+              <a:t>"The Kingdom is pressed into..."</a:t>
+            </a:r>
+          </a:p>
+          <a:p>
+            <a:pPr>
               <a:defRPr sz="1600"/>
             </a:pPr>
             <a:r>
-              <a:t>Stood alone on Mount Carmel</a:t>
-            </a:r>
-          </a:p>
-          <a:p>
-            <a:pPr>
-              <a:defRPr sz="1800"/>
-            </a:pPr>
-            <a:r>
-              <a:t>Crushing produces oil</a:t>
-            </a:r>
-          </a:p>
-          <a:p>
-            <a:pPr>
-              <a:defRPr sz="1800"/>
-            </a:pPr>
-            <a:r>
-              <a:t>Jesus said: Luke 16:16</a:t>
-            </a:r>
-          </a:p>
-          <a:p>
-            <a:pPr>
-              <a:defRPr sz="1800"/>
-            </a:pPr>
-            <a:r>
-              <a:t>"The Kingdom is pressed into..."</a:t>
-            </a:r>
-          </a:p>
-          <a:p>
-            <a:pPr>
-              <a:defRPr sz="1800"/>
-            </a:pPr>
-            <a:r>
               <a:t>Pressing = pursuit, hunger, surrender</a:t>
             </a:r>
           </a:p>
           <a:p>
             <a:pPr>
-              <a:defRPr sz="1800"/>
+              <a:defRPr sz="1600"/>
             </a:pPr>
             <a:r>
               <a:t>Prayer is the pressing</a:t>
@@ -3893,6 +4095,30 @@
           </a:p>
         </p:txBody>
       </p:sp>
+      <p:pic>
+        <p:nvPicPr>
+          <p:cNvPr id="4" name="Picture 3" descr="05-pressing-oil.png"/>
+          <p:cNvPicPr>
+            <a:picLocks noChangeAspect="1"/>
+          </p:cNvPicPr>
+          <p:nvPr/>
+        </p:nvPicPr>
+        <p:blipFill>
+          <a:blip r:embed="rId2"/>
+          <a:stretch>
+            <a:fillRect/>
+          </a:stretch>
+        </p:blipFill>
+        <p:spPr>
+          <a:xfrm>
+            <a:off x="7040880" y="1143000"/>
+            <a:ext cx="4663440" cy="4663440"/>
+          </a:xfrm>
+          <a:prstGeom prst="rect">
+            <a:avLst/>
+          </a:prstGeom>
+        </p:spPr>
+      </p:pic>
     </p:spTree>
   </p:cSld>
   <p:clrMapOvr>
@@ -3921,11 +4147,19 @@
             <p:ph type="title"/>
           </p:nvPr>
         </p:nvSpPr>
-        <p:spPr/>
-        <p:txBody>
-          <a:bodyPr/>
-          <a:lstStyle/>
-          <a:p>
+        <p:spPr>
+          <a:xfrm>
+            <a:off x="457200" y="320040"/>
+            <a:ext cx="6675120" cy="822960"/>
+          </a:xfrm>
+        </p:spPr>
+        <p:txBody>
+          <a:bodyPr/>
+          <a:lstStyle/>
+          <a:p>
+            <a:pPr>
+              <a:defRPr sz="3400"/>
+            </a:pPr>
             <a:r>
               <a:t>4) TEN VIRGINS - PREPARATION</a:t>
             </a:r>
@@ -3942,13 +4176,18 @@
             <p:ph idx="1"/>
           </p:nvPr>
         </p:nvSpPr>
-        <p:spPr/>
-        <p:txBody>
-          <a:bodyPr/>
-          <a:lstStyle/>
-          <a:p>
-            <a:pPr>
-              <a:defRPr sz="1800"/>
+        <p:spPr>
+          <a:xfrm>
+            <a:off x="548640" y="1188720"/>
+            <a:ext cx="6309360" cy="5303520"/>
+          </a:xfrm>
+        </p:spPr>
+        <p:txBody>
+          <a:bodyPr wrap="square"/>
+          <a:lstStyle/>
+          <a:p>
+            <a:pPr>
+              <a:defRPr sz="1600"/>
             </a:pPr>
             <a:r>
               <a:t>Matthew 25: Ten virgins</a:t>
@@ -3956,7 +4195,7 @@
           </a:p>
           <a:p>
             <a:pPr>
-              <a:defRPr sz="1800"/>
+              <a:defRPr sz="1600"/>
             </a:pPr>
             <a:r>
               <a:t>All waiting, all sleeping, midnight cry</a:t>
@@ -3964,7 +4203,7 @@
           </a:p>
           <a:p>
             <a:pPr>
-              <a:defRPr sz="1800"/>
+              <a:defRPr sz="1600"/>
             </a:pPr>
             <a:r>
               <a:t>Only five had oil</a:t>
@@ -3972,7 +4211,7 @@
           </a:p>
           <a:p>
             <a:pPr>
-              <a:defRPr sz="1800"/>
+              <a:defRPr sz="1600"/>
             </a:pPr>
             <a:r>
               <a:t>Preparation happens before sudden moments</a:t>
@@ -3980,7 +4219,7 @@
           </a:p>
           <a:p>
             <a:pPr>
-              <a:defRPr sz="1800"/>
+              <a:defRPr sz="1600"/>
             </a:pPr>
             <a:r>
               <a:t>Elijah appeared suddenly - but he was prepared</a:t>
@@ -3988,7 +4227,7 @@
           </a:p>
           <a:p>
             <a:pPr>
-              <a:defRPr sz="1800"/>
+              <a:defRPr sz="1600"/>
             </a:pPr>
             <a:r>
               <a:t>Question: If midnight came tonight, would we be ready?</a:t>
@@ -3996,6 +4235,30 @@
           </a:p>
         </p:txBody>
       </p:sp>
+      <p:pic>
+        <p:nvPicPr>
+          <p:cNvPr id="4" name="Picture 3" descr="06-ten-virgins.png"/>
+          <p:cNvPicPr>
+            <a:picLocks noChangeAspect="1"/>
+          </p:cNvPicPr>
+          <p:nvPr/>
+        </p:nvPicPr>
+        <p:blipFill>
+          <a:blip r:embed="rId2"/>
+          <a:stretch>
+            <a:fillRect/>
+          </a:stretch>
+        </p:blipFill>
+        <p:spPr>
+          <a:xfrm>
+            <a:off x="7040880" y="1143000"/>
+            <a:ext cx="4663440" cy="4663440"/>
+          </a:xfrm>
+          <a:prstGeom prst="rect">
+            <a:avLst/>
+          </a:prstGeom>
+        </p:spPr>
+      </p:pic>
     </p:spTree>
   </p:cSld>
   <p:clrMapOvr>
@@ -4024,11 +4287,19 @@
             <p:ph type="title"/>
           </p:nvPr>
         </p:nvSpPr>
-        <p:spPr/>
-        <p:txBody>
-          <a:bodyPr/>
-          <a:lstStyle/>
-          <a:p>
+        <p:spPr>
+          <a:xfrm>
+            <a:off x="457200" y="320040"/>
+            <a:ext cx="6675120" cy="822960"/>
+          </a:xfrm>
+        </p:spPr>
+        <p:txBody>
+          <a:bodyPr/>
+          <a:lstStyle/>
+          <a:p>
+            <a:pPr>
+              <a:defRPr sz="3400"/>
+            </a:pPr>
             <a:r>
               <a:t>5) TESTIFY</a:t>
             </a:r>
@@ -4045,13 +4316,18 @@
             <p:ph idx="1"/>
           </p:nvPr>
         </p:nvSpPr>
-        <p:spPr/>
-        <p:txBody>
-          <a:bodyPr/>
-          <a:lstStyle/>
-          <a:p>
-            <a:pPr>
-              <a:defRPr sz="1800"/>
+        <p:spPr>
+          <a:xfrm>
+            <a:off x="548640" y="1188720"/>
+            <a:ext cx="6309360" cy="5303520"/>
+          </a:xfrm>
+        </p:spPr>
+        <p:txBody>
+          <a:bodyPr wrap="square"/>
+          <a:lstStyle/>
+          <a:p>
+            <a:pPr>
+              <a:defRPr sz="1500"/>
             </a:pPr>
             <a:r>
               <a:t>During the drought:</a:t>
@@ -4059,7 +4335,7 @@
           </a:p>
           <a:p>
             <a:pPr lvl="1">
-              <a:defRPr sz="1600"/>
+              <a:defRPr sz="1300"/>
             </a:pPr>
             <a:r>
               <a:t>Widow's flour and oil did not run out</a:t>
@@ -4067,7 +4343,7 @@
           </a:p>
           <a:p>
             <a:pPr lvl="1">
-              <a:defRPr sz="1600"/>
+              <a:defRPr sz="1300"/>
             </a:pPr>
             <a:r>
               <a:t>Widow's son was raised</a:t>
@@ -4075,7 +4351,7 @@
           </a:p>
           <a:p>
             <a:pPr lvl="1">
-              <a:defRPr sz="1600"/>
+              <a:defRPr sz="1300"/>
             </a:pPr>
             <a:r>
               <a:t>Fire fell from heaven</a:t>
@@ -4083,7 +4359,7 @@
           </a:p>
           <a:p>
             <a:pPr lvl="1">
-              <a:defRPr sz="1600"/>
+              <a:defRPr sz="1300"/>
             </a:pPr>
             <a:r>
               <a:t>Rain returned</a:t>
@@ -4091,7 +4367,7 @@
           </a:p>
           <a:p>
             <a:pPr>
-              <a:defRPr sz="1800"/>
+              <a:defRPr sz="1500"/>
             </a:pPr>
             <a:r>
               <a:t>People recognized God:</a:t>
@@ -4099,7 +4375,7 @@
           </a:p>
           <a:p>
             <a:pPr lvl="1">
-              <a:defRPr sz="1600"/>
+              <a:defRPr sz="1300"/>
             </a:pPr>
             <a:r>
               <a:t>Yahweh = "I AM"</a:t>
@@ -4107,7 +4383,7 @@
           </a:p>
           <a:p>
             <a:pPr>
-              <a:defRPr sz="1800"/>
+              <a:defRPr sz="1500"/>
             </a:pPr>
             <a:r>
               <a:t>Revival happens when people recognize who God is</a:t>
@@ -4115,7 +4391,7 @@
           </a:p>
           <a:p>
             <a:pPr>
-              <a:defRPr sz="1800"/>
+              <a:defRPr sz="1500"/>
             </a:pPr>
             <a:r>
               <a:t>We testify Jesus - John 14:6</a:t>
@@ -4123,7 +4399,7 @@
           </a:p>
           <a:p>
             <a:pPr lvl="1">
-              <a:defRPr sz="1600"/>
+              <a:defRPr sz="1300"/>
             </a:pPr>
             <a:r>
               <a:t>Way -&gt; Watch and follow Him</a:t>
@@ -4131,7 +4407,7 @@
           </a:p>
           <a:p>
             <a:pPr lvl="1">
-              <a:defRPr sz="1600"/>
+              <a:defRPr sz="1300"/>
             </a:pPr>
             <a:r>
               <a:t>Truth -&gt; Testify boldly</a:t>
@@ -4139,7 +4415,7 @@
           </a:p>
           <a:p>
             <a:pPr lvl="1">
-              <a:defRPr sz="1600"/>
+              <a:defRPr sz="1300"/>
             </a:pPr>
             <a:r>
               <a:t>Life -&gt; Listen and abide</a:t>
@@ -4147,6 +4423,30 @@
           </a:p>
         </p:txBody>
       </p:sp>
+      <p:pic>
+        <p:nvPicPr>
+          <p:cNvPr id="4" name="Picture 3" descr="07-testify.png"/>
+          <p:cNvPicPr>
+            <a:picLocks noChangeAspect="1"/>
+          </p:cNvPicPr>
+          <p:nvPr/>
+        </p:nvPicPr>
+        <p:blipFill>
+          <a:blip r:embed="rId2"/>
+          <a:stretch>
+            <a:fillRect/>
+          </a:stretch>
+        </p:blipFill>
+        <p:spPr>
+          <a:xfrm>
+            <a:off x="7040880" y="1143000"/>
+            <a:ext cx="4663440" cy="4663440"/>
+          </a:xfrm>
+          <a:prstGeom prst="rect">
+            <a:avLst/>
+          </a:prstGeom>
+        </p:spPr>
+      </p:pic>
     </p:spTree>
   </p:cSld>
   <p:clrMapOvr>
@@ -4175,11 +4475,19 @@
             <p:ph type="title"/>
           </p:nvPr>
         </p:nvSpPr>
-        <p:spPr/>
-        <p:txBody>
-          <a:bodyPr/>
-          <a:lstStyle/>
-          <a:p>
+        <p:spPr>
+          <a:xfrm>
+            <a:off x="457200" y="320040"/>
+            <a:ext cx="6675120" cy="822960"/>
+          </a:xfrm>
+        </p:spPr>
+        <p:txBody>
+          <a:bodyPr/>
+          <a:lstStyle/>
+          <a:p>
+            <a:pPr>
+              <a:defRPr sz="3400"/>
+            </a:pPr>
             <a:r>
               <a:t>6) ALIGNMENT - THE GUARDRAIL</a:t>
             </a:r>
@@ -4196,13 +4504,18 @@
             <p:ph idx="1"/>
           </p:nvPr>
         </p:nvSpPr>
-        <p:spPr/>
-        <p:txBody>
-          <a:bodyPr/>
-          <a:lstStyle/>
-          <a:p>
-            <a:pPr>
-              <a:defRPr sz="1800"/>
+        <p:spPr>
+          <a:xfrm>
+            <a:off x="548640" y="1188720"/>
+            <a:ext cx="6309360" cy="5303520"/>
+          </a:xfrm>
+        </p:spPr>
+        <p:txBody>
+          <a:bodyPr wrap="square"/>
+          <a:lstStyle/>
+          <a:p>
+            <a:pPr>
+              <a:defRPr sz="1600"/>
             </a:pPr>
             <a:r>
               <a:t>Warning: We do not release power at will</a:t>
@@ -4210,7 +4523,7 @@
           </a:p>
           <a:p>
             <a:pPr>
-              <a:defRPr sz="1800"/>
+              <a:defRPr sz="1600"/>
             </a:pPr>
             <a:r>
               <a:t>Jesus: "I do nothing on My own"</a:t>
@@ -4218,7 +4531,7 @@
           </a:p>
           <a:p>
             <a:pPr>
-              <a:defRPr sz="1800"/>
+              <a:defRPr sz="1600"/>
             </a:pPr>
             <a:r>
               <a:t>Kingdom authority flows from alignment</a:t>
@@ -4226,7 +4539,7 @@
           </a:p>
           <a:p>
             <a:pPr>
-              <a:defRPr sz="1800"/>
+              <a:defRPr sz="1600"/>
             </a:pPr>
             <a:r>
               <a:t>Oil = relationship maintained, not power controlled</a:t>
@@ -4234,6 +4547,30 @@
           </a:p>
         </p:txBody>
       </p:sp>
+      <p:pic>
+        <p:nvPicPr>
+          <p:cNvPr id="4" name="Picture 3" descr="08-alignment.png"/>
+          <p:cNvPicPr>
+            <a:picLocks noChangeAspect="1"/>
+          </p:cNvPicPr>
+          <p:nvPr/>
+        </p:nvPicPr>
+        <p:blipFill>
+          <a:blip r:embed="rId2"/>
+          <a:stretch>
+            <a:fillRect/>
+          </a:stretch>
+        </p:blipFill>
+        <p:spPr>
+          <a:xfrm>
+            <a:off x="7040880" y="1143000"/>
+            <a:ext cx="4663440" cy="4663440"/>
+          </a:xfrm>
+          <a:prstGeom prst="rect">
+            <a:avLst/>
+          </a:prstGeom>
+        </p:spPr>
+      </p:pic>
     </p:spTree>
   </p:cSld>
   <p:clrMapOvr>
@@ -4262,11 +4599,19 @@
             <p:ph type="title"/>
           </p:nvPr>
         </p:nvSpPr>
-        <p:spPr/>
-        <p:txBody>
-          <a:bodyPr/>
-          <a:lstStyle/>
-          <a:p>
+        <p:spPr>
+          <a:xfrm>
+            <a:off x="457200" y="320040"/>
+            <a:ext cx="6675120" cy="822960"/>
+          </a:xfrm>
+        </p:spPr>
+        <p:txBody>
+          <a:bodyPr/>
+          <a:lstStyle/>
+          <a:p>
+            <a:pPr>
+              <a:defRPr sz="3400"/>
+            </a:pPr>
             <a:r>
               <a:t>MODERN APPLICATION</a:t>
             </a:r>
@@ -4283,13 +4628,18 @@
             <p:ph idx="1"/>
           </p:nvPr>
         </p:nvSpPr>
-        <p:spPr/>
-        <p:txBody>
-          <a:bodyPr/>
-          <a:lstStyle/>
-          <a:p>
-            <a:pPr>
-              <a:defRPr sz="1800"/>
+        <p:spPr>
+          <a:xfrm>
+            <a:off x="548640" y="1188720"/>
+            <a:ext cx="6309360" cy="5303520"/>
+          </a:xfrm>
+        </p:spPr>
+        <p:txBody>
+          <a:bodyPr wrap="square"/>
+          <a:lstStyle/>
+          <a:p>
+            <a:pPr>
+              <a:defRPr sz="1600"/>
             </a:pPr>
             <a:r>
               <a:t>Spirit dwells in us today</a:t>
@@ -4297,7 +4647,7 @@
           </a:p>
           <a:p>
             <a:pPr>
-              <a:defRPr sz="1800"/>
+              <a:defRPr sz="1600"/>
             </a:pPr>
             <a:r>
               <a:t>Kingdom flows through surrender</a:t>
@@ -4305,7 +4655,7 @@
           </a:p>
           <a:p>
             <a:pPr>
-              <a:defRPr sz="1800"/>
+              <a:defRPr sz="1600"/>
             </a:pPr>
             <a:r>
               <a:t>For Deaf believers:</a:t>
@@ -4313,54 +4663,78 @@
           </a:p>
           <a:p>
             <a:pPr lvl="1">
+              <a:defRPr sz="1400"/>
+            </a:pPr>
+            <a:r>
+              <a:t>You may not hear sound, but you discern spiritually</a:t>
+            </a:r>
+          </a:p>
+          <a:p>
+            <a:pPr>
               <a:defRPr sz="1600"/>
             </a:pPr>
             <a:r>
-              <a:t>You may not hear sound, but you discern spiritually</a:t>
-            </a:r>
-          </a:p>
-          <a:p>
-            <a:pPr>
-              <a:defRPr sz="1800"/>
-            </a:pPr>
-            <a:r>
               <a:t>God is raising:</a:t>
             </a:r>
           </a:p>
           <a:p>
             <a:pPr lvl="1">
+              <a:defRPr sz="1400"/>
+            </a:pPr>
+            <a:r>
+              <a:t>Watchmen</a:t>
+            </a:r>
+          </a:p>
+          <a:p>
+            <a:pPr lvl="1">
+              <a:defRPr sz="1400"/>
+            </a:pPr>
+            <a:r>
+              <a:t>Prayer warriors</a:t>
+            </a:r>
+          </a:p>
+          <a:p>
+            <a:pPr lvl="1">
+              <a:defRPr sz="1400"/>
+            </a:pPr>
+            <a:r>
+              <a:t>Faithful witnesses</a:t>
+            </a:r>
+          </a:p>
+          <a:p>
+            <a:pPr>
               <a:defRPr sz="1600"/>
             </a:pPr>
             <a:r>
-              <a:t>Watchmen</a:t>
-            </a:r>
-          </a:p>
-          <a:p>
-            <a:pPr lvl="1">
-              <a:defRPr sz="1600"/>
-            </a:pPr>
-            <a:r>
-              <a:t>Prayer warriors</a:t>
-            </a:r>
-          </a:p>
-          <a:p>
-            <a:pPr lvl="1">
-              <a:defRPr sz="1600"/>
-            </a:pPr>
-            <a:r>
-              <a:t>Faithful witnesses</a:t>
-            </a:r>
-          </a:p>
-          <a:p>
-            <a:pPr>
-              <a:defRPr sz="1800"/>
-            </a:pPr>
-            <a:r>
               <a:t>James 5:16 - The prayer of the righteous is powerful and effective</a:t>
             </a:r>
           </a:p>
         </p:txBody>
       </p:sp>
+      <p:pic>
+        <p:nvPicPr>
+          <p:cNvPr id="4" name="Picture 3" descr="09-modern-application.png"/>
+          <p:cNvPicPr>
+            <a:picLocks noChangeAspect="1"/>
+          </p:cNvPicPr>
+          <p:nvPr/>
+        </p:nvPicPr>
+        <p:blipFill>
+          <a:blip r:embed="rId2"/>
+          <a:stretch>
+            <a:fillRect/>
+          </a:stretch>
+        </p:blipFill>
+        <p:spPr>
+          <a:xfrm>
+            <a:off x="7040880" y="1143000"/>
+            <a:ext cx="4663440" cy="4663440"/>
+          </a:xfrm>
+          <a:prstGeom prst="rect">
+            <a:avLst/>
+          </a:prstGeom>
+        </p:spPr>
+      </p:pic>
     </p:spTree>
   </p:cSld>
   <p:clrMapOvr>

</xml_diff>